<commit_message>
feat: remove Rupee Exit Trail; drop dead top-bar icons
- Rupee Exit Trail screen, route, nav item and links removed; marked out of
  scope in the plan and backend docs (nav is now 9 sections).
- Apps-grid, notifications and messages icons removed from the top bar
  (they had no behaviour).
- Video script and deck updated: the deck's Rupee Exit lines now describe
  crime-type (typology) detection instead.

Co-Authored-By: Claude Opus 5.5 <noreply@anthropic.com>
</commit_message>
<xml_diff>
--- a/deck/ANVESHAK_SIH26182.pptx
+++ b/deck/ANVESHAK_SIH26182.pptx
@@ -6808,11 +6808,11 @@
               </a:pPr>
               <a:r>
                 <a:rPr lang="en-IN" sz="1300" b="1" dirty="0"/>
-                <a:t>Follows the rupee</a:t>
+                <a:t>Names the crime type</a:t>
               </a:r>
               <a:r>
                 <a:rPr lang="en-IN" sz="1300" dirty="0"/>
-                <a:t> out of crypto into UPI mule accounts.</a:t>
+                <a:t> — scam, ransomware, darknet or terror-financing signs.</a:t>
               </a:r>
             </a:p>
             <a:p>
@@ -8247,11 +8247,11 @@
               </a:r>
               <a:r>
                 <a:rPr lang="en-IN" sz="1340" b="1" dirty="0"/>
-                <a:t> Rupee Exit Trail:</a:t>
+                <a:t> Crime-Type Detection:</a:t>
               </a:r>
               <a:r>
                 <a:rPr lang="en-IN" sz="1340" dirty="0"/>
-                <a:t> follows money out of crypto into UPI mule accounts.</a:t>
+                <a:t> scam, ransomware, darknet or terror signs, with the maths shown.</a:t>
               </a:r>
             </a:p>
             <a:p>

</xml_diff>